<commit_message>
docs: condense Slide 2 bullets for presentation clarity
</commit_message>
<xml_diff>
--- a/VibeTune_Project_Presentation.pptx
+++ b/VibeTune_Project_Presentation.pptx
@@ -5082,7 +5082,7 @@
                 </a:solidFill>
                 <a:latin typeface="Segoe UI"/>
               </a:rPr>
-              <a:t>React 19 &amp; TypeScript Strict Architecture: </a:t>
+              <a:t>React 19 &amp; TypeScript: </a:t>
             </a:r>
             <a:r>
               <a:rPr lang="en-US" sz="1350" b="0" dirty="0">
@@ -5091,7 +5091,7 @@
                 </a:solidFill>
                 <a:latin typeface="Segoe UI"/>
               </a:rPr>
-              <a:t>Engineered reusable, modular UI components enforced with compile-time type contracts, interfaces, and verbatimModuleSyntax.</a:t>
+              <a:t>Modular, strictly-typed component architecture ensuring compile-time reliability.</a:t>
             </a:r>
           </a:p>
           <a:p>
@@ -5112,7 +5112,7 @@
                 </a:solidFill>
                 <a:latin typeface="Segoe UI"/>
               </a:rPr>
-              <a:t>Web Audio API &amp; HTML5 Dual-Engine: </a:t>
+              <a:t>Web Audio API Dual-Engine: </a:t>
             </a:r>
             <a:r>
               <a:rPr lang="en-US" sz="1350" b="0" dirty="0">
@@ -5121,7 +5121,7 @@
                 </a:solidFill>
                 <a:latin typeface="Segoe UI"/>
               </a:rPr>
-              <a:t>Designed a custom dual-engine audio pipeline utilizing AudioContext, GainNode crossfaders, and BiquadFilters for zero-latency client processing.</a:t>
+              <a:t>Low-latency browser sound routing with dynamic GainNode crossfading and filters.</a:t>
             </a:r>
           </a:p>
           <a:p>
@@ -5142,7 +5142,7 @@
                 </a:solidFill>
                 <a:latin typeface="Segoe UI"/>
               </a:rPr>
-              <a:t>Modern Responsive Design System: </a:t>
+              <a:t>Modern Responsive UI: </a:t>
             </a:r>
             <a:r>
               <a:rPr lang="en-US" sz="1350" b="0" dirty="0">
@@ -5151,7 +5151,7 @@
                 </a:solidFill>
                 <a:latin typeface="Segoe UI"/>
               </a:rPr>
-              <a:t>Developed an immersive glassmorphic UI using Tailwind CSS v4 with dynamic backdrop-blurs, custom seekbars, and mobile-first layouts.</a:t>
+              <a:t>Fluid glassmorphic design crafted with Tailwind CSS v4 across mobile and desktop.</a:t>
             </a:r>
           </a:p>
           <a:p>
@@ -5172,7 +5172,7 @@
                 </a:solidFill>
                 <a:latin typeface="Segoe UI"/>
               </a:rPr>
-              <a:t>State Architecture &amp; Local Vault Engine: </a:t>
+              <a:t>Context API &amp; Local Vault: </a:t>
             </a:r>
             <a:r>
               <a:rPr lang="en-US" sz="1350" b="0" dirty="0">
@@ -5181,7 +5181,7 @@
                 </a:solidFill>
                 <a:latin typeface="Segoe UI"/>
               </a:rPr>
-              <a:t>Created centralized state via React Context API (useReducer pattern) paired with HTML5 File &amp; Blob APIs for secure offline audio playback.</a:t>
+              <a:t>Centralized global state with 100% offline, privacy-first playback using Blob URLs.</a:t>
             </a:r>
           </a:p>
           <a:p>
@@ -5202,7 +5202,7 @@
                 </a:solidFill>
                 <a:latin typeface="Segoe UI"/>
               </a:rPr>
-              <a:t>Production Containerization &amp; DevOps: </a:t>
+              <a:t>Docker &amp; Cloud DevOps: </a:t>
             </a:r>
             <a:r>
               <a:rPr lang="en-US" sz="1350" b="0" dirty="0">
@@ -5211,7 +5211,7 @@
                 </a:solidFill>
                 <a:latin typeface="Segoe UI"/>
               </a:rPr>
-              <a:t>Configured multi-stage Docker builds with alpine Nginx, automated GitHub workflows, and AWS EC2 cloud hosting.</a:t>
+              <a:t>Multi-stage containerization with Alpine Nginx, GitHub CI/CD, and AWS EC2 hosting.</a:t>
             </a:r>
           </a:p>
         </p:txBody>

</xml_diff>

<commit_message>
docs: match reference PPT template concise format exactly
</commit_message>
<xml_diff>
--- a/VibeTune_Project_Presentation.pptx
+++ b/VibeTune_Project_Presentation.pptx
@@ -4815,7 +4815,7 @@
                   <a:schemeClr val="bg1"/>
                 </a:solidFill>
               </a:rPr>
-              <a:t>Date: October 2026</a:t>
+              <a:t>Date: 30-10-2026</a:t>
             </a:r>
           </a:p>
         </p:txBody>
@@ -4886,7 +4886,7 @@
                   <a:schemeClr val="bg1"/>
                 </a:solidFill>
               </a:rPr>
-              <a:t>Internal Guide:</a:t>
+              <a:t>Guide:</a:t>
             </a:r>
           </a:p>
           <a:p>
@@ -4896,17 +4896,7 @@
                   <a:schemeClr val="bg1"/>
                 </a:solidFill>
               </a:rPr>
-              <a:t>Mr. Shaik Meer Subhani Ali</a:t>
-            </a:r>
-          </a:p>
-          <a:p>
-            <a:r>
-              <a:rPr lang="en-US" sz="1200">
-                <a:solidFill>
-                  <a:schemeClr val="bg1"/>
-                </a:solidFill>
-              </a:rPr>
-              <a:t>Assistant Professor, Dept. of CSE (AI &amp; ML)</a:t>
+              <a:t>Mr Shaik Meer Subhani Ali</a:t>
             </a:r>
           </a:p>
         </p:txBody>
@@ -4939,7 +4929,7 @@
                   <a:schemeClr val="bg1"/>
                 </a:solidFill>
               </a:rPr>
-              <a:t>Presented By:</a:t>
+              <a:t>Student details:</a:t>
             </a:r>
           </a:p>
           <a:p>
@@ -4949,17 +4939,7 @@
                   <a:schemeClr val="bg1"/>
                 </a:solidFill>
               </a:rPr>
-              <a:t>G. Veena</a:t>
-            </a:r>
-          </a:p>
-          <a:p>
-            <a:r>
-              <a:rPr lang="en-US" sz="1200">
-                <a:solidFill>
-                  <a:schemeClr val="bg1"/>
-                </a:solidFill>
-              </a:rPr>
-              <a:t>Roll No: 23E51Axxxx | III Year B.Tech (CSE - AI &amp; ML)</a:t>
+              <a:t>G. Veena    (23E51Axxxx)</a:t>
             </a:r>
           </a:p>
         </p:txBody>
@@ -5065,24 +5045,24 @@
           </a:bodyPr>
           <a:lstStyle/>
           <a:p>
-            <a:pPr marL="342900" indent="-285750" algn="l">
+            <a:pPr marL="300000" indent="-220000" algn="l">
               <a:lnSpc>
-                <a:spcPct val="115000"/>
+                <a:spcPct val="110000"/>
               </a:lnSpc>
               <a:spcBef>
-                <a:spcPct val="35000"/>
+                <a:spcPct val="25000"/>
               </a:spcBef>
               <a:buFont typeface="Arial"/>
               <a:buChar char="•"/>
             </a:pPr>
             <a:r>
-              <a:rPr lang="en-US" sz="1500" b="1" dirty="0">
+              <a:rPr lang="en-US" sz="1350" b="1" dirty="0">
                 <a:solidFill>
                   <a:srgbClr val="0F172A"/>
                 </a:solidFill>
                 <a:latin typeface="Segoe UI"/>
               </a:rPr>
-              <a:t>React 19 &amp; TypeScript: </a:t>
+              <a:t>Frontend Development: </a:t>
             </a:r>
             <a:r>
               <a:rPr lang="en-US" sz="1350" b="0" dirty="0">
@@ -5091,28 +5071,28 @@
                 </a:solidFill>
                 <a:latin typeface="Segoe UI"/>
               </a:rPr>
-              <a:t>Modular, strictly-typed component architecture ensuring compile-time reliability.</a:t>
-            </a:r>
-          </a:p>
-          <a:p>
-            <a:pPr marL="342900" indent="-285750" algn="l">
+              <a:t>React 19, TypeScript, and Vite for building high-performance web components.</a:t>
+            </a:r>
+          </a:p>
+          <a:p>
+            <a:pPr marL="300000" indent="-220000" algn="l">
               <a:lnSpc>
-                <a:spcPct val="115000"/>
+                <a:spcPct val="110000"/>
               </a:lnSpc>
               <a:spcBef>
-                <a:spcPct val="35000"/>
+                <a:spcPct val="25000"/>
               </a:spcBef>
               <a:buFont typeface="Arial"/>
               <a:buChar char="•"/>
             </a:pPr>
             <a:r>
-              <a:rPr lang="en-US" sz="1500" b="1" dirty="0">
+              <a:rPr lang="en-US" sz="1350" b="1" dirty="0">
                 <a:solidFill>
                   <a:srgbClr val="0F172A"/>
                 </a:solidFill>
                 <a:latin typeface="Segoe UI"/>
               </a:rPr>
-              <a:t>Web Audio API Dual-Engine: </a:t>
+              <a:t>Audio Engineering: </a:t>
             </a:r>
             <a:r>
               <a:rPr lang="en-US" sz="1350" b="0" dirty="0">
@@ -5121,28 +5101,28 @@
                 </a:solidFill>
                 <a:latin typeface="Segoe UI"/>
               </a:rPr>
-              <a:t>Low-latency browser sound routing with dynamic GainNode crossfading and filters.</a:t>
-            </a:r>
-          </a:p>
-          <a:p>
-            <a:pPr marL="342900" indent="-285750" algn="l">
+              <a:t>HTML5 Audio and Web Audio API for playback, gain crossfading, and audio filtering.</a:t>
+            </a:r>
+          </a:p>
+          <a:p>
+            <a:pPr marL="300000" indent="-220000" algn="l">
               <a:lnSpc>
-                <a:spcPct val="115000"/>
+                <a:spcPct val="110000"/>
               </a:lnSpc>
               <a:spcBef>
-                <a:spcPct val="35000"/>
+                <a:spcPct val="25000"/>
               </a:spcBef>
               <a:buFont typeface="Arial"/>
               <a:buChar char="•"/>
             </a:pPr>
             <a:r>
-              <a:rPr lang="en-US" sz="1500" b="1" dirty="0">
+              <a:rPr lang="en-US" sz="1350" b="1" dirty="0">
                 <a:solidFill>
                   <a:srgbClr val="0F172A"/>
                 </a:solidFill>
                 <a:latin typeface="Segoe UI"/>
               </a:rPr>
-              <a:t>Modern Responsive UI: </a:t>
+              <a:t>Styling &amp; UI Design: </a:t>
             </a:r>
             <a:r>
               <a:rPr lang="en-US" sz="1350" b="0" dirty="0">
@@ -5151,28 +5131,28 @@
                 </a:solidFill>
                 <a:latin typeface="Segoe UI"/>
               </a:rPr>
-              <a:t>Fluid glassmorphic design crafted with Tailwind CSS v4 across mobile and desktop.</a:t>
-            </a:r>
-          </a:p>
-          <a:p>
-            <a:pPr marL="342900" indent="-285750" algn="l">
+              <a:t>Tailwind CSS v4 for creating responsive, glassmorphic interfaces across all screens.</a:t>
+            </a:r>
+          </a:p>
+          <a:p>
+            <a:pPr marL="300000" indent="-220000" algn="l">
               <a:lnSpc>
-                <a:spcPct val="115000"/>
+                <a:spcPct val="110000"/>
               </a:lnSpc>
               <a:spcBef>
-                <a:spcPct val="35000"/>
+                <a:spcPct val="25000"/>
               </a:spcBef>
               <a:buFont typeface="Arial"/>
               <a:buChar char="•"/>
             </a:pPr>
             <a:r>
-              <a:rPr lang="en-US" sz="1500" b="1" dirty="0">
+              <a:rPr lang="en-US" sz="1350" b="1" dirty="0">
                 <a:solidFill>
                   <a:srgbClr val="0F172A"/>
                 </a:solidFill>
                 <a:latin typeface="Segoe UI"/>
               </a:rPr>
-              <a:t>Context API &amp; Local Vault: </a:t>
+              <a:t>State Management: </a:t>
             </a:r>
             <a:r>
               <a:rPr lang="en-US" sz="1350" b="0" dirty="0">
@@ -5181,28 +5161,28 @@
                 </a:solidFill>
                 <a:latin typeface="Segoe UI"/>
               </a:rPr>
-              <a:t>Centralized global state with 100% offline, privacy-first playback using Blob URLs.</a:t>
-            </a:r>
-          </a:p>
-          <a:p>
-            <a:pPr marL="342900" indent="-285750" algn="l">
+              <a:t>React Context API for managing active audio state, queue controls, and favorites.</a:t>
+            </a:r>
+          </a:p>
+          <a:p>
+            <a:pPr marL="300000" indent="-220000" algn="l">
               <a:lnSpc>
-                <a:spcPct val="115000"/>
+                <a:spcPct val="110000"/>
               </a:lnSpc>
               <a:spcBef>
-                <a:spcPct val="35000"/>
+                <a:spcPct val="25000"/>
               </a:spcBef>
               <a:buFont typeface="Arial"/>
               <a:buChar char="•"/>
             </a:pPr>
             <a:r>
-              <a:rPr lang="en-US" sz="1500" b="1" dirty="0">
+              <a:rPr lang="en-US" sz="1350" b="1" dirty="0">
                 <a:solidFill>
                   <a:srgbClr val="0F172A"/>
                 </a:solidFill>
                 <a:latin typeface="Segoe UI"/>
               </a:rPr>
-              <a:t>Docker &amp; Cloud DevOps: </a:t>
+              <a:t>Storage &amp; Privacy: </a:t>
             </a:r>
             <a:r>
               <a:rPr lang="en-US" sz="1350" b="0" dirty="0">
@@ -5211,7 +5191,67 @@
                 </a:solidFill>
                 <a:latin typeface="Segoe UI"/>
               </a:rPr>
-              <a:t>Multi-stage containerization with Alpine Nginx, GitHub CI/CD, and AWS EC2 hosting.</a:t>
+              <a:t>HTML5 File and Blob APIs for secure, offline audio playback with zero cloud uploads.</a:t>
+            </a:r>
+          </a:p>
+          <a:p>
+            <a:pPr marL="300000" indent="-220000" algn="l">
+              <a:lnSpc>
+                <a:spcPct val="110000"/>
+              </a:lnSpc>
+              <a:spcBef>
+                <a:spcPct val="25000"/>
+              </a:spcBef>
+              <a:buFont typeface="Arial"/>
+              <a:buChar char="•"/>
+            </a:pPr>
+            <a:r>
+              <a:rPr lang="en-US" sz="1350" b="1" dirty="0">
+                <a:solidFill>
+                  <a:srgbClr val="0F172A"/>
+                </a:solidFill>
+                <a:latin typeface="Segoe UI"/>
+              </a:rPr>
+              <a:t>Version Control: </a:t>
+            </a:r>
+            <a:r>
+              <a:rPr lang="en-US" sz="1350" b="0" dirty="0">
+                <a:solidFill>
+                  <a:srgbClr val="334155"/>
+                </a:solidFill>
+                <a:latin typeface="Segoe UI"/>
+              </a:rPr>
+              <a:t>Git and GitHub for source-code management and repository hosting.</a:t>
+            </a:r>
+          </a:p>
+          <a:p>
+            <a:pPr marL="300000" indent="-220000" algn="l">
+              <a:lnSpc>
+                <a:spcPct val="110000"/>
+              </a:lnSpc>
+              <a:spcBef>
+                <a:spcPct val="25000"/>
+              </a:spcBef>
+              <a:buFont typeface="Arial"/>
+              <a:buChar char="•"/>
+            </a:pPr>
+            <a:r>
+              <a:rPr lang="en-US" sz="1350" b="1" dirty="0">
+                <a:solidFill>
+                  <a:srgbClr val="0F172A"/>
+                </a:solidFill>
+                <a:latin typeface="Segoe UI"/>
+              </a:rPr>
+              <a:t>Cloud &amp; DevOps: </a:t>
+            </a:r>
+            <a:r>
+              <a:rPr lang="en-US" sz="1350" b="0" dirty="0">
+                <a:solidFill>
+                  <a:srgbClr val="334155"/>
+                </a:solidFill>
+                <a:latin typeface="Segoe UI"/>
+              </a:rPr>
+              <a:t>AWS EC2, Ubuntu Server, Nginx, and Docker for containerized deployment.</a:t>
             </a:r>
           </a:p>
         </p:txBody>
@@ -5321,115 +5361,100 @@
           </a:bodyPr>
           <a:lstStyle/>
           <a:p>
-            <a:pPr marL="342900" indent="-285750" algn="l">
+            <a:pPr marL="300000" indent="-220000" algn="l">
               <a:lnSpc>
-                <a:spcPct val="115000"/>
+                <a:spcPct val="110000"/>
               </a:lnSpc>
               <a:spcBef>
-                <a:spcPct val="35000"/>
+                <a:spcPct val="25000"/>
               </a:spcBef>
               <a:buFont typeface="Arial"/>
               <a:buChar char="•"/>
             </a:pPr>
             <a:r>
-              <a:rPr lang="en-US" sz="1500" b="1" dirty="0">
-                <a:solidFill>
-                  <a:srgbClr val="0F172A"/>
+              <a:rPr lang="en-US" sz="1350" b="0" dirty="0">
+                <a:solidFill>
+                  <a:srgbClr val="334155"/>
                 </a:solidFill>
                 <a:latin typeface="Segoe UI"/>
               </a:rPr>
-              <a:t>Eliminating Paywalls &amp; Authentication Friction: </a:t>
-            </a:r>
-            <a:r>
-              <a:rPr lang="en-US" sz="1350" b="0" dirty="0">
-                <a:solidFill>
-                  <a:srgbClr val="334155"/>
-                </a:solidFill>
-                <a:latin typeface="Segoe UI"/>
-              </a:rPr>
-              <a:t>Overcame commercial streaming hurdles (Spotify/Apple Music paywalls) by designing a completely free, frictionless web player requiring zero sign-ins.</a:t>
-            </a:r>
-          </a:p>
-          <a:p>
-            <a:pPr marL="342900" indent="-285750" algn="l">
+              <a:t>Identified user friction with commercial streaming platforms (paywalls, forced logins, restricted queues).</a:t>
+            </a:r>
+          </a:p>
+          <a:p>
+            <a:pPr marL="300000" indent="-220000" algn="l">
               <a:lnSpc>
-                <a:spcPct val="115000"/>
+                <a:spcPct val="110000"/>
               </a:lnSpc>
               <a:spcBef>
-                <a:spcPct val="35000"/>
+                <a:spcPct val="25000"/>
               </a:spcBef>
               <a:buFont typeface="Arial"/>
               <a:buChar char="•"/>
             </a:pPr>
             <a:r>
-              <a:rPr lang="en-US" sz="1500" b="1" dirty="0">
-                <a:solidFill>
-                  <a:srgbClr val="0F172A"/>
+              <a:rPr lang="en-US" sz="1350" b="0" dirty="0">
+                <a:solidFill>
+                  <a:srgbClr val="334155"/>
                 </a:solidFill>
                 <a:latin typeface="Segoe UI"/>
               </a:rPr>
-              <a:t>Audio Discontinuity &amp; Abrupt Transitions: </a:t>
-            </a:r>
-            <a:r>
-              <a:rPr lang="en-US" sz="1350" b="0" dirty="0">
-                <a:solidFill>
-                  <a:srgbClr val="334155"/>
-                </a:solidFill>
-                <a:latin typeface="Segoe UI"/>
-              </a:rPr>
-              <a:t>Eliminated harsh track transitions by engineering an intelligent exponential gain-ramp crossfading algorithm, preserving study focus.</a:t>
-            </a:r>
-          </a:p>
-          <a:p>
-            <a:pPr marL="342900" indent="-285750" algn="l">
+              <a:t>Designed a frictionless, open web player requiring no account creation or login.</a:t>
+            </a:r>
+          </a:p>
+          <a:p>
+            <a:pPr marL="300000" indent="-220000" algn="l">
               <a:lnSpc>
-                <a:spcPct val="115000"/>
+                <a:spcPct val="110000"/>
               </a:lnSpc>
               <a:spcBef>
-                <a:spcPct val="35000"/>
+                <a:spcPct val="25000"/>
               </a:spcBef>
               <a:buFont typeface="Arial"/>
               <a:buChar char="•"/>
             </a:pPr>
             <a:r>
-              <a:rPr lang="en-US" sz="1500" b="1" dirty="0">
-                <a:solidFill>
-                  <a:srgbClr val="0F172A"/>
+              <a:rPr lang="en-US" sz="1350" b="0" dirty="0">
+                <a:solidFill>
+                  <a:srgbClr val="334155"/>
                 </a:solidFill>
                 <a:latin typeface="Segoe UI"/>
               </a:rPr>
-              <a:t>Privacy &amp; Zero-Cost Storage with Local Vault: </a:t>
-            </a:r>
-            <a:r>
-              <a:rPr lang="en-US" sz="1350" b="0" dirty="0">
-                <a:solidFill>
-                  <a:srgbClr val="334155"/>
-                </a:solidFill>
-                <a:latin typeface="Segoe UI"/>
-              </a:rPr>
-              <a:t>Solved cloud storage costs and personal data exposure by executing 100% client-side blob rendering for user MP3/WAV files with zero server storage overhead.</a:t>
-            </a:r>
-          </a:p>
-          <a:p>
-            <a:pPr marL="342900" indent="-285750" algn="l">
+              <a:t>Eliminated abrupt song transitions by implementing an intelligent gain-ramp crossfade algorithm.</a:t>
+            </a:r>
+          </a:p>
+          <a:p>
+            <a:pPr marL="300000" indent="-220000" algn="l">
               <a:lnSpc>
-                <a:spcPct val="115000"/>
+                <a:spcPct val="110000"/>
               </a:lnSpc>
               <a:spcBef>
-                <a:spcPct val="35000"/>
+                <a:spcPct val="25000"/>
               </a:spcBef>
               <a:buFont typeface="Arial"/>
               <a:buChar char="•"/>
             </a:pPr>
             <a:r>
-              <a:rPr lang="en-US" sz="1500" b="1" dirty="0">
-                <a:solidFill>
-                  <a:srgbClr val="0F172A"/>
+              <a:rPr lang="en-US" sz="1350" b="0" dirty="0">
+                <a:solidFill>
+                  <a:srgbClr val="334155"/>
                 </a:solidFill>
                 <a:latin typeface="Segoe UI"/>
               </a:rPr>
-              <a:t>Bridging Music Streaming with Deep Productivity: </a:t>
-            </a:r>
+              <a:t>Addressed personal file privacy and cloud storage costs using browser-native Blob URLs (Local Vault).</a:t>
+            </a:r>
+          </a:p>
+          <a:p>
+            <a:pPr marL="300000" indent="-220000" algn="l">
+              <a:lnSpc>
+                <a:spcPct val="110000"/>
+              </a:lnSpc>
+              <a:spcBef>
+                <a:spcPct val="25000"/>
+              </a:spcBef>
+              <a:buFont typeface="Arial"/>
+              <a:buChar char="•"/>
+            </a:pPr>
             <a:r>
               <a:rPr lang="en-US" sz="1350" b="0" dirty="0">
                 <a:solidFill>
@@ -5437,7 +5462,28 @@
                 </a:solidFill>
                 <a:latin typeface="Segoe UI"/>
               </a:rPr>
-              <a:t>Addressed context-switching between audio players and study tools by integrating a Pomodoro focus timer with auto-pausing audio triggers and ambient noise synthesis.</a:t>
+              <a:t>Integrated a Pomodoro focus timer with auto-pausing audio triggers to merge music with productivity.</a:t>
+            </a:r>
+          </a:p>
+          <a:p>
+            <a:pPr marL="300000" indent="-220000" algn="l">
+              <a:lnSpc>
+                <a:spcPct val="110000"/>
+              </a:lnSpc>
+              <a:spcBef>
+                <a:spcPct val="25000"/>
+              </a:spcBef>
+              <a:buFont typeface="Arial"/>
+              <a:buChar char="•"/>
+            </a:pPr>
+            <a:r>
+              <a:rPr lang="en-US" sz="1350" b="0" dirty="0">
+                <a:solidFill>
+                  <a:srgbClr val="334155"/>
+                </a:solidFill>
+                <a:latin typeface="Segoe UI"/>
+              </a:rPr>
+              <a:t>Resolved TypeScript strict build errors, audio state lag, and cross-browser playback inconsistencies.</a:t>
             </a:r>
           </a:p>
         </p:txBody>
@@ -5556,54 +5602,79 @@
           </a:bodyPr>
           <a:lstStyle/>
           <a:p>
-            <a:pPr marL="342900" indent="-285750" algn="l">
+            <a:pPr algn="l">
+              <a:spcBef>
+                <a:spcPct val="40000"/>
+              </a:spcBef>
+              <a:buNone/>
+            </a:pPr>
+            <a:r>
+              <a:rPr lang="en-US" sz="1500" b="1">
+                <a:solidFill>
+                  <a:srgbClr val="1E3A8A"/>
+                </a:solidFill>
+                <a:latin typeface="Segoe UI"/>
+              </a:rPr>
+              <a:t>System Architecture:</a:t>
+            </a:r>
+          </a:p>
+          <a:p>
+            <a:pPr marL="300000" indent="-220000" algn="l">
               <a:lnSpc>
-                <a:spcPct val="115000"/>
+                <a:spcPct val="110000"/>
               </a:lnSpc>
               <a:spcBef>
-                <a:spcPct val="35000"/>
+                <a:spcPct val="25000"/>
               </a:spcBef>
               <a:buFont typeface="Arial"/>
               <a:buChar char="•"/>
             </a:pPr>
             <a:r>
-              <a:rPr lang="en-US" sz="1500" b="1" dirty="0">
-                <a:solidFill>
-                  <a:srgbClr val="0F172A"/>
+              <a:rPr lang="en-US" sz="1350" b="0" dirty="0">
+                <a:solidFill>
+                  <a:srgbClr val="334155"/>
                 </a:solidFill>
                 <a:latin typeface="Segoe UI"/>
               </a:rPr>
-              <a:t>Decoupled Three-Tier Client Architecture: </a:t>
-            </a:r>
-            <a:r>
-              <a:rPr lang="en-US" sz="1350" b="0" dirty="0">
-                <a:solidFill>
-                  <a:srgbClr val="334155"/>
+              <a:t>Developer -&gt; GitHub -&gt; Docker -&gt; AWS EC2 -&gt; Nginx -&gt; User Browser</a:t>
+            </a:r>
+          </a:p>
+          <a:p>
+            <a:pPr algn="l">
+              <a:spcBef>
+                <a:spcPct val="40000"/>
+              </a:spcBef>
+              <a:buNone/>
+            </a:pPr>
+            <a:r>
+              <a:rPr lang="en-US" sz="1500" b="1">
+                <a:solidFill>
+                  <a:srgbClr val="1E3A8A"/>
                 </a:solidFill>
                 <a:latin typeface="Segoe UI"/>
               </a:rPr>
-              <a:t>Structured into UI Presentation Layer (React 19 components), Global Context State (VibeTuneContext), and Native Audio Pipeline (audioEngine.ts).</a:t>
-            </a:r>
-          </a:p>
-          <a:p>
-            <a:pPr marL="342900" indent="-285750" algn="l">
+              <a:t>Application Components:</a:t>
+            </a:r>
+          </a:p>
+          <a:p>
+            <a:pPr marL="300000" indent="-220000" algn="l">
               <a:lnSpc>
-                <a:spcPct val="115000"/>
+                <a:spcPct val="110000"/>
               </a:lnSpc>
               <a:spcBef>
-                <a:spcPct val="35000"/>
+                <a:spcPct val="25000"/>
               </a:spcBef>
               <a:buFont typeface="Arial"/>
               <a:buChar char="•"/>
             </a:pPr>
             <a:r>
-              <a:rPr lang="en-US" sz="1500" b="1" dirty="0">
+              <a:rPr lang="en-US" sz="1350" b="1" dirty="0">
                 <a:solidFill>
                   <a:srgbClr val="0F172A"/>
                 </a:solidFill>
                 <a:latin typeface="Segoe UI"/>
               </a:rPr>
-              <a:t>Core Functional Modules: </a:t>
+              <a:t>Frontend: </a:t>
             </a:r>
             <a:r>
               <a:rPr lang="en-US" sz="1350" b="0" dirty="0">
@@ -5612,28 +5683,28 @@
                 </a:solidFill>
                 <a:latin typeface="Segoe UI"/>
               </a:rPr>
-              <a:t>Engineered AudioPlayer (waveform seekbar, volume control, queue drawer), AI Vibe Studio (prompt-driven mood playlist generation), and Focus Mode (Pomodoro intervals).</a:t>
-            </a:r>
-          </a:p>
-          <a:p>
-            <a:pPr marL="342900" indent="-285750" algn="l">
+              <a:t>React 19, TypeScript, and Tailwind CSS v4.</a:t>
+            </a:r>
+          </a:p>
+          <a:p>
+            <a:pPr marL="300000" indent="-220000" algn="l">
               <a:lnSpc>
-                <a:spcPct val="115000"/>
+                <a:spcPct val="110000"/>
               </a:lnSpc>
               <a:spcBef>
-                <a:spcPct val="35000"/>
+                <a:spcPct val="25000"/>
               </a:spcBef>
               <a:buFont typeface="Arial"/>
               <a:buChar char="•"/>
             </a:pPr>
             <a:r>
-              <a:rPr lang="en-US" sz="1500" b="1" dirty="0">
+              <a:rPr lang="en-US" sz="1350" b="1" dirty="0">
                 <a:solidFill>
                   <a:srgbClr val="0F172A"/>
                 </a:solidFill>
                 <a:latin typeface="Segoe UI"/>
               </a:rPr>
-              <a:t>Smart Search &amp; Queue Optimization: </a:t>
+              <a:t>Audio Engine: </a:t>
             </a:r>
             <a:r>
               <a:rPr lang="en-US" sz="1350" b="0" dirty="0">
@@ -5642,28 +5713,28 @@
                 </a:solidFill>
                 <a:latin typeface="Segoe UI"/>
               </a:rPr>
-              <a:t>Implemented real-time fuzzy filtering over tracks, artists, albums, and tags with O(1) queue insertion and dynamic shuffle algorithms.</a:t>
-            </a:r>
-          </a:p>
-          <a:p>
-            <a:pPr marL="342900" indent="-285750" algn="l">
+              <a:t>HTML5 Media Streams &amp; Web Audio API (audioEngine.ts).</a:t>
+            </a:r>
+          </a:p>
+          <a:p>
+            <a:pPr marL="300000" indent="-220000" algn="l">
               <a:lnSpc>
-                <a:spcPct val="115000"/>
+                <a:spcPct val="110000"/>
               </a:lnSpc>
               <a:spcBef>
-                <a:spcPct val="35000"/>
+                <a:spcPct val="25000"/>
               </a:spcBef>
               <a:buFont typeface="Arial"/>
               <a:buChar char="•"/>
             </a:pPr>
             <a:r>
-              <a:rPr lang="en-US" sz="1500" b="1" dirty="0">
+              <a:rPr lang="en-US" sz="1350" b="1" dirty="0">
                 <a:solidFill>
                   <a:srgbClr val="0F172A"/>
                 </a:solidFill>
                 <a:latin typeface="Segoe UI"/>
               </a:rPr>
-              <a:t>Local Audio Vault: </a:t>
+              <a:t>State &amp; Storage: </a:t>
             </a:r>
             <a:r>
               <a:rPr lang="en-US" sz="1350" b="0" dirty="0">
@@ -5672,28 +5743,28 @@
                 </a:solidFill>
                 <a:latin typeface="Segoe UI"/>
               </a:rPr>
-              <a:t>Engineered drag-and-drop file ingestion using HTML5 File API and URL.createObjectURL for instant, memory-efficient offline audio playback.</a:t>
-            </a:r>
-          </a:p>
-          <a:p>
-            <a:pPr marL="342900" indent="-285750" algn="l">
+              <a:t>React Context API (VibeTuneContext) and HTML5 Blob URLs.</a:t>
+            </a:r>
+          </a:p>
+          <a:p>
+            <a:pPr marL="300000" indent="-220000" algn="l">
               <a:lnSpc>
-                <a:spcPct val="115000"/>
+                <a:spcPct val="110000"/>
               </a:lnSpc>
               <a:spcBef>
-                <a:spcPct val="35000"/>
+                <a:spcPct val="25000"/>
               </a:spcBef>
               <a:buFont typeface="Arial"/>
               <a:buChar char="•"/>
             </a:pPr>
             <a:r>
-              <a:rPr lang="en-US" sz="1500" b="1" dirty="0">
+              <a:rPr lang="en-US" sz="1350" b="1" dirty="0">
                 <a:solidFill>
                   <a:srgbClr val="0F172A"/>
                 </a:solidFill>
                 <a:latin typeface="Segoe UI"/>
               </a:rPr>
-              <a:t>Deployment &amp; Version Control Pipeline: </a:t>
+              <a:t>Cloud &amp; Server: </a:t>
             </a:r>
             <a:r>
               <a:rPr lang="en-US" sz="1350" b="0" dirty="0">
@@ -5702,7 +5773,129 @@
                 </a:solidFill>
                 <a:latin typeface="Segoe UI"/>
               </a:rPr>
-              <a:t>Maintained modular Git branch commits pushed to GitHub (github.com/Veena2708/vibe-tune) and containerized with Docker.</a:t>
+              <a:t>AWS EC2 Ubuntu Server, Nginx web server, and Docker.</a:t>
+            </a:r>
+          </a:p>
+          <a:p>
+            <a:pPr algn="l">
+              <a:spcBef>
+                <a:spcPct val="40000"/>
+              </a:spcBef>
+              <a:buNone/>
+            </a:pPr>
+            <a:r>
+              <a:rPr lang="en-US" sz="1500" b="1">
+                <a:solidFill>
+                  <a:srgbClr val="1E3A8A"/>
+                </a:solidFill>
+                <a:latin typeface="Segoe UI"/>
+              </a:rPr>
+              <a:t>Implementation Workflow:</a:t>
+            </a:r>
+          </a:p>
+          <a:p>
+            <a:pPr marL="300000" indent="-220000" algn="l">
+              <a:lnSpc>
+                <a:spcPct val="110000"/>
+              </a:lnSpc>
+              <a:spcBef>
+                <a:spcPct val="25000"/>
+              </a:spcBef>
+              <a:buFont typeface="Arial"/>
+              <a:buChar char="•"/>
+            </a:pPr>
+            <a:r>
+              <a:rPr lang="en-US" sz="1300" b="0" dirty="0">
+                <a:solidFill>
+                  <a:srgbClr val="334155"/>
+                </a:solidFill>
+                <a:latin typeface="Segoe UI"/>
+              </a:rPr>
+              <a:t>1. Develop modular React components and the core dual-audio engine.</a:t>
+            </a:r>
+          </a:p>
+          <a:p>
+            <a:pPr marL="300000" indent="-220000" algn="l">
+              <a:lnSpc>
+                <a:spcPct val="110000"/>
+              </a:lnSpc>
+              <a:spcBef>
+                <a:spcPct val="25000"/>
+              </a:spcBef>
+              <a:buFont typeface="Arial"/>
+              <a:buChar char="•"/>
+            </a:pPr>
+            <a:r>
+              <a:rPr lang="en-US" sz="1300" b="0" dirty="0">
+                <a:solidFill>
+                  <a:srgbClr val="334155"/>
+                </a:solidFill>
+                <a:latin typeface="Segoe UI"/>
+              </a:rPr>
+              <a:t>2. Manage source code and version tracking using GitHub.</a:t>
+            </a:r>
+          </a:p>
+          <a:p>
+            <a:pPr marL="300000" indent="-220000" algn="l">
+              <a:lnSpc>
+                <a:spcPct val="110000"/>
+              </a:lnSpc>
+              <a:spcBef>
+                <a:spcPct val="25000"/>
+              </a:spcBef>
+              <a:buFont typeface="Arial"/>
+              <a:buChar char="•"/>
+            </a:pPr>
+            <a:r>
+              <a:rPr lang="en-US" sz="1300" b="0" dirty="0">
+                <a:solidFill>
+                  <a:srgbClr val="334155"/>
+                </a:solidFill>
+                <a:latin typeface="Segoe UI"/>
+              </a:rPr>
+              <a:t>3. Containerize the production application using multi-stage Docker builds.</a:t>
+            </a:r>
+          </a:p>
+          <a:p>
+            <a:pPr marL="300000" indent="-220000" algn="l">
+              <a:lnSpc>
+                <a:spcPct val="110000"/>
+              </a:lnSpc>
+              <a:spcBef>
+                <a:spcPct val="25000"/>
+              </a:spcBef>
+              <a:buFont typeface="Arial"/>
+              <a:buChar char="•"/>
+            </a:pPr>
+            <a:r>
+              <a:rPr lang="en-US" sz="1300" b="0" dirty="0">
+                <a:solidFill>
+                  <a:srgbClr val="334155"/>
+                </a:solidFill>
+                <a:latin typeface="Segoe UI"/>
+              </a:rPr>
+              <a:t>4. Deploy and serve the application on an AWS EC2 instance using Nginx.</a:t>
+            </a:r>
+          </a:p>
+          <a:p>
+            <a:pPr marL="300000" indent="-220000" algn="l">
+              <a:lnSpc>
+                <a:spcPct val="110000"/>
+              </a:lnSpc>
+              <a:spcBef>
+                <a:spcPct val="25000"/>
+              </a:spcBef>
+              <a:buFont typeface="Arial"/>
+              <a:buChar char="•"/>
+            </a:pPr>
+            <a:r>
+              <a:rPr lang="en-US" sz="1300" b="0" dirty="0">
+                <a:solidFill>
+                  <a:srgbClr val="334155"/>
+                </a:solidFill>
+                <a:latin typeface="Segoe UI"/>
+              </a:rPr>
+              <a:t>5. Verify audio streaming, focus timer automation, and local file playback.</a:t>
             </a:r>
           </a:p>
         </p:txBody>
@@ -5781,153 +5974,247 @@
           <a:bodyPr/>
           <a:lstStyle/>
           <a:p>
-            <a:pPr marL="342900" indent="-285750" algn="l">
+            <a:pPr algn="l">
+              <a:spcBef>
+                <a:spcPct val="40000"/>
+              </a:spcBef>
+              <a:buNone/>
+            </a:pPr>
+            <a:r>
+              <a:rPr lang="en-US" sz="1500" b="1">
+                <a:solidFill>
+                  <a:srgbClr val="1E3A8A"/>
+                </a:solidFill>
+                <a:latin typeface="Segoe UI"/>
+              </a:rPr>
+              <a:t>Project Results:</a:t>
+            </a:r>
+          </a:p>
+          <a:p>
+            <a:pPr marL="300000" indent="-220000" algn="l">
               <a:lnSpc>
-                <a:spcPct val="115000"/>
+                <a:spcPct val="110000"/>
               </a:lnSpc>
               <a:spcBef>
-                <a:spcPct val="35000"/>
+                <a:spcPct val="25000"/>
               </a:spcBef>
               <a:buFont typeface="Arial"/>
               <a:buChar char="•"/>
             </a:pPr>
             <a:r>
-              <a:rPr lang="en-US" sz="1500" b="1" dirty="0">
-                <a:solidFill>
-                  <a:srgbClr val="0F172A"/>
+              <a:rPr lang="en-US" sz="1350" b="0" dirty="0">
+                <a:solidFill>
+                  <a:srgbClr val="334155"/>
                 </a:solidFill>
                 <a:latin typeface="Segoe UI"/>
               </a:rPr>
-              <a:t>Ultra-Fast Performance &amp; Build Optimization: </a:t>
-            </a:r>
-            <a:r>
-              <a:rPr lang="en-US" sz="1350" b="0" dirty="0">
-                <a:solidFill>
-                  <a:srgbClr val="334155"/>
-                </a:solidFill>
-                <a:latin typeface="Segoe UI"/>
-              </a:rPr>
-              <a:t>Vite 7 build compiles in &lt;1.2s with gzipped bundle size &lt;160 KB. Achieved 98+ Google Lighthouse Performance and 100% Accessibility score.</a:t>
-            </a:r>
-          </a:p>
-          <a:p>
-            <a:pPr marL="342900" indent="-285750" algn="l">
+              <a:t>Developed a responsive web platform combining music streaming with productivity tools.</a:t>
+            </a:r>
+          </a:p>
+          <a:p>
+            <a:pPr marL="300000" indent="-220000" algn="l">
               <a:lnSpc>
-                <a:spcPct val="115000"/>
+                <a:spcPct val="110000"/>
               </a:lnSpc>
               <a:spcBef>
-                <a:spcPct val="35000"/>
+                <a:spcPct val="25000"/>
               </a:spcBef>
               <a:buFont typeface="Arial"/>
               <a:buChar char="•"/>
             </a:pPr>
             <a:r>
-              <a:rPr lang="en-US" sz="1500" b="1" dirty="0">
-                <a:solidFill>
-                  <a:srgbClr val="0F172A"/>
+              <a:rPr lang="en-US" sz="1350" b="0" dirty="0">
+                <a:solidFill>
+                  <a:srgbClr val="334155"/>
                 </a:solidFill>
                 <a:latin typeface="Segoe UI"/>
               </a:rPr>
-              <a:t>Sub-50ms Playback Initialization: </a:t>
-            </a:r>
-            <a:r>
-              <a:rPr lang="en-US" sz="1350" b="0" dirty="0">
-                <a:solidFill>
-                  <a:srgbClr val="334155"/>
-                </a:solidFill>
-                <a:latin typeface="Segoe UI"/>
-              </a:rPr>
-              <a:t>Dual-engine audio pipeline initiates remote streams and local blob audio in under 50ms with seamless seek scrubbing and zero buffer stall.</a:t>
-            </a:r>
-          </a:p>
-          <a:p>
-            <a:pPr marL="342900" indent="-285750" algn="l">
+              <a:t>Enabled instant playback across remote curated tracks, AI mood playlists, and local files.</a:t>
+            </a:r>
+          </a:p>
+          <a:p>
+            <a:pPr marL="300000" indent="-220000" algn="l">
               <a:lnSpc>
-                <a:spcPct val="115000"/>
+                <a:spcPct val="110000"/>
               </a:lnSpc>
               <a:spcBef>
-                <a:spcPct val="35000"/>
+                <a:spcPct val="25000"/>
               </a:spcBef>
               <a:buFont typeface="Arial"/>
               <a:buChar char="•"/>
             </a:pPr>
             <a:r>
-              <a:rPr lang="en-US" sz="1500" b="1" dirty="0">
-                <a:solidFill>
-                  <a:srgbClr val="0F172A"/>
+              <a:rPr lang="en-US" sz="1350" b="0" dirty="0">
+                <a:solidFill>
+                  <a:srgbClr val="334155"/>
                 </a:solidFill>
                 <a:latin typeface="Segoe UI"/>
               </a:rPr>
-              <a:t>Cross-Browser &amp; Multi-Device Validation: </a:t>
-            </a:r>
-            <a:r>
-              <a:rPr lang="en-US" sz="1350" b="0" dirty="0">
-                <a:solidFill>
-                  <a:srgbClr val="334155"/>
-                </a:solidFill>
-                <a:latin typeface="Segoe UI"/>
-              </a:rPr>
-              <a:t>Extensively verified on Chromium, Gecko (Firefox), and WebKit (Safari) across Mobile (375px), Tablet (768px), and Desktop (1080p/4K) viewports.</a:t>
-            </a:r>
-          </a:p>
-          <a:p>
-            <a:pPr marL="342900" indent="-285750" algn="l">
+              <a:t>Integrated a custom audio engine featuring seamless crossfading and real-time audio controls.</a:t>
+            </a:r>
+          </a:p>
+          <a:p>
+            <a:pPr marL="300000" indent="-220000" algn="l">
               <a:lnSpc>
-                <a:spcPct val="115000"/>
+                <a:spcPct val="110000"/>
               </a:lnSpc>
               <a:spcBef>
-                <a:spcPct val="35000"/>
+                <a:spcPct val="25000"/>
               </a:spcBef>
               <a:buFont typeface="Arial"/>
               <a:buChar char="•"/>
             </a:pPr>
             <a:r>
-              <a:rPr lang="en-US" sz="1500" b="1" dirty="0">
-                <a:solidFill>
-                  <a:srgbClr val="0F172A"/>
+              <a:rPr lang="en-US" sz="1350" b="0" dirty="0">
+                <a:solidFill>
+                  <a:srgbClr val="334155"/>
                 </a:solidFill>
                 <a:latin typeface="Segoe UI"/>
               </a:rPr>
-              <a:t>Focus Mode Automation Accuracy: </a:t>
-            </a:r>
-            <a:r>
-              <a:rPr lang="en-US" sz="1350" b="0" dirty="0">
-                <a:solidFill>
-                  <a:srgbClr val="334155"/>
-                </a:solidFill>
-                <a:latin typeface="Segoe UI"/>
-              </a:rPr>
-              <a:t>Validated 25m work / 5m break interval cycles, smooth audio volume ducking on timer expiration, and audio state preservation.</a:t>
-            </a:r>
-          </a:p>
-          <a:p>
-            <a:pPr marL="342900" indent="-285750" algn="l">
+              <a:t>Created a modern glassmorphic interface fully responsive across mobile, tablet, and desktop.</a:t>
+            </a:r>
+          </a:p>
+          <a:p>
+            <a:pPr marL="300000" indent="-220000" algn="l">
               <a:lnSpc>
-                <a:spcPct val="115000"/>
+                <a:spcPct val="110000"/>
               </a:lnSpc>
               <a:spcBef>
-                <a:spcPct val="35000"/>
+                <a:spcPct val="25000"/>
               </a:spcBef>
               <a:buFont typeface="Arial"/>
               <a:buChar char="•"/>
             </a:pPr>
             <a:r>
-              <a:rPr lang="en-US" sz="1500" b="1" dirty="0">
-                <a:solidFill>
-                  <a:srgbClr val="0F172A"/>
+              <a:rPr lang="en-US" sz="1350" b="0" dirty="0">
+                <a:solidFill>
+                  <a:srgbClr val="334155"/>
                 </a:solidFill>
                 <a:latin typeface="Segoe UI"/>
               </a:rPr>
-              <a:t>Stress &amp; Queue Capacity Testing: </a:t>
-            </a:r>
-            <a:r>
-              <a:rPr lang="en-US" sz="1350" b="0" dirty="0">
-                <a:solidFill>
-                  <a:srgbClr val="334155"/>
+              <a:t>Established a containerized deployment workflow using Docker and AWS EC2.</a:t>
+            </a:r>
+          </a:p>
+          <a:p>
+            <a:pPr algn="l">
+              <a:spcBef>
+                <a:spcPct val="40000"/>
+              </a:spcBef>
+              <a:buNone/>
+            </a:pPr>
+            <a:r>
+              <a:rPr lang="en-US" sz="1500" b="1">
+                <a:solidFill>
+                  <a:srgbClr val="1E3A8A"/>
                 </a:solidFill>
                 <a:latin typeface="Segoe UI"/>
               </a:rPr>
-              <a:t>Successfully stress-tested playback queue with 500+ items maintaining 60 FPS animations, smooth scrolling, and zero memory leaks.</a:t>
+              <a:t>Testing Performed:</a:t>
+            </a:r>
+          </a:p>
+          <a:p>
+            <a:pPr marL="300000" indent="-220000" algn="l">
+              <a:lnSpc>
+                <a:spcPct val="110000"/>
+              </a:lnSpc>
+              <a:spcBef>
+                <a:spcPct val="25000"/>
+              </a:spcBef>
+              <a:buFont typeface="Arial"/>
+              <a:buChar char="•"/>
+            </a:pPr>
+            <a:r>
+              <a:rPr lang="en-US" sz="1350" b="0" dirty="0">
+                <a:solidFill>
+                  <a:srgbClr val="334155"/>
+                </a:solidFill>
+                <a:latin typeface="Segoe UI"/>
+              </a:rPr>
+              <a:t>Checked audio player controls (play, pause, seek, volume, shuffle, and queue management).</a:t>
+            </a:r>
+          </a:p>
+          <a:p>
+            <a:pPr marL="300000" indent="-220000" algn="l">
+              <a:lnSpc>
+                <a:spcPct val="110000"/>
+              </a:lnSpc>
+              <a:spcBef>
+                <a:spcPct val="25000"/>
+              </a:spcBef>
+              <a:buFont typeface="Arial"/>
+              <a:buChar char="•"/>
+            </a:pPr>
+            <a:r>
+              <a:rPr lang="en-US" sz="1350" b="0" dirty="0">
+                <a:solidFill>
+                  <a:srgbClr val="334155"/>
+                </a:solidFill>
+                <a:latin typeface="Segoe UI"/>
+              </a:rPr>
+              <a:t>Verified drag-and-drop local audio file playback using the Local Vault.</a:t>
+            </a:r>
+          </a:p>
+          <a:p>
+            <a:pPr marL="300000" indent="-220000" algn="l">
+              <a:lnSpc>
+                <a:spcPct val="110000"/>
+              </a:lnSpc>
+              <a:spcBef>
+                <a:spcPct val="25000"/>
+              </a:spcBef>
+              <a:buFont typeface="Arial"/>
+              <a:buChar char="•"/>
+            </a:pPr>
+            <a:r>
+              <a:rPr lang="en-US" sz="1350" b="0" dirty="0">
+                <a:solidFill>
+                  <a:srgbClr val="334155"/>
+                </a:solidFill>
+                <a:latin typeface="Segoe UI"/>
+              </a:rPr>
+              <a:t>Tested Pomodoro timer intervals and audio ducking upon timer completion.</a:t>
+            </a:r>
+          </a:p>
+          <a:p>
+            <a:pPr marL="300000" indent="-220000" algn="l">
+              <a:lnSpc>
+                <a:spcPct val="110000"/>
+              </a:lnSpc>
+              <a:spcBef>
+                <a:spcPct val="25000"/>
+              </a:spcBef>
+              <a:buFont typeface="Arial"/>
+              <a:buChar char="•"/>
+            </a:pPr>
+            <a:r>
+              <a:rPr lang="en-US" sz="1350" b="0" dirty="0">
+                <a:solidFill>
+                  <a:srgbClr val="334155"/>
+                </a:solidFill>
+                <a:latin typeface="Segoe UI"/>
+              </a:rPr>
+              <a:t>Verified responsive UI layouts across mobile (375px), tablet (768px), and desktop (1080p).</a:t>
+            </a:r>
+          </a:p>
+          <a:p>
+            <a:pPr marL="300000" indent="-220000" algn="l">
+              <a:lnSpc>
+                <a:spcPct val="110000"/>
+              </a:lnSpc>
+              <a:spcBef>
+                <a:spcPct val="25000"/>
+              </a:spcBef>
+              <a:buFont typeface="Arial"/>
+              <a:buChar char="•"/>
+            </a:pPr>
+            <a:r>
+              <a:rPr lang="en-US" sz="1350" b="0" dirty="0">
+                <a:solidFill>
+                  <a:srgbClr val="334155"/>
+                </a:solidFill>
+                <a:latin typeface="Segoe UI"/>
+              </a:rPr>
+              <a:t>Tested production build stability, Lighthouse performance (98+), and Docker container execution.</a:t>
             </a:r>
           </a:p>
         </p:txBody>
@@ -5980,40 +6267,14 @@
           </a:bodyPr>
           <a:lstStyle/>
           <a:p>
-            <a:pPr algn="ctr">
-              <a:lnSpc>
-                <a:spcPct val="150000"/>
-              </a:lnSpc>
-            </a:pPr>
-            <a:r>
-              <a:rPr lang="en-IN" sz="6000" b="1" dirty="0"/>
-              <a:t>THANK YOU</a:t>
-            </a:r>
-          </a:p>
-          <a:p>
-            <a:pPr algn="ctr">
-              <a:spcBef>
-                <a:spcPct val="50000"/>
-              </a:spcBef>
-            </a:pPr>
-            <a:r>
-              <a:rPr lang="en-US" sz="1800" b="1">
-                <a:solidFill>
-                  <a:srgbClr val="E2E8F0"/>
+            <a:pPr algn="ctr"/>
+            <a:r>
+              <a:rPr lang="en-US" sz="5500" b="1">
+                <a:solidFill>
+                  <a:schemeClr val="bg1"/>
                 </a:solidFill>
               </a:rPr>
-              <a:t>VibeTune: AI Music Streaming &amp; Productivity Suite</a:t>
-            </a:r>
-          </a:p>
-          <a:p>
-            <a:pPr algn="ctr"/>
-            <a:r>
-              <a:rPr lang="en-US" sz="1400" b="0">
-                <a:solidFill>
-                  <a:srgbClr val="CBD5E1"/>
-                </a:solidFill>
-              </a:rPr>
-              <a:t>GitHub: https://github.com/Veena2708/vibe-tune  |  Local: http://localhost:5173</a:t>
+              <a:t>THANK YOU!</a:t>
             </a:r>
           </a:p>
         </p:txBody>

</xml_diff>